<commit_message>
chunk 4 und 5 überarbeitet
</commit_message>
<xml_diff>
--- a/Lectures/Chunk 4 - Lists and Tuples.pptx
+++ b/Lectures/Chunk 4 - Lists and Tuples.pptx
@@ -134,6 +134,99 @@
 
 <file path=ppt/changesInfos/changesInfo1.xml><?xml version="1.0" encoding="utf-8"?>
 <pc:chgInfo xmlns:a="http://schemas.openxmlformats.org/drawingml/2006/main" xmlns:r="http://schemas.openxmlformats.org/officeDocument/2006/relationships" xmlns:ac="http://schemas.microsoft.com/office/drawing/2013/main/command" xmlns:pc="http://schemas.microsoft.com/office/powerpoint/2013/main/command">
+  <pc:docChgLst>
+    <pc:chgData name="Jonathan Bollig" userId="8b5d0afe-f106-45e0-8c3f-fd98fa124db1" providerId="ADAL" clId="{891409C9-2319-433B-8001-2E1CE368518E}"/>
+    <pc:docChg chg="custSel addSld delSld modSld">
+      <pc:chgData name="Jonathan Bollig" userId="8b5d0afe-f106-45e0-8c3f-fd98fa124db1" providerId="ADAL" clId="{891409C9-2319-433B-8001-2E1CE368518E}" dt="2025-08-18T13:33:56.347" v="46" actId="47"/>
+      <pc:docMkLst>
+        <pc:docMk/>
+      </pc:docMkLst>
+      <pc:sldChg chg="modSp mod">
+        <pc:chgData name="Jonathan Bollig" userId="8b5d0afe-f106-45e0-8c3f-fd98fa124db1" providerId="ADAL" clId="{891409C9-2319-433B-8001-2E1CE368518E}" dt="2025-08-18T10:03:07.320" v="7" actId="20577"/>
+        <pc:sldMkLst>
+          <pc:docMk/>
+          <pc:sldMk cId="836289018" sldId="256"/>
+        </pc:sldMkLst>
+      </pc:sldChg>
+      <pc:sldChg chg="del">
+        <pc:chgData name="Jonathan Bollig" userId="8b5d0afe-f106-45e0-8c3f-fd98fa124db1" providerId="ADAL" clId="{891409C9-2319-433B-8001-2E1CE368518E}" dt="2025-08-18T09:57:07.527" v="0" actId="47"/>
+        <pc:sldMkLst>
+          <pc:docMk/>
+          <pc:sldMk cId="3656329933" sldId="257"/>
+        </pc:sldMkLst>
+      </pc:sldChg>
+      <pc:sldChg chg="del">
+        <pc:chgData name="Jonathan Bollig" userId="8b5d0afe-f106-45e0-8c3f-fd98fa124db1" providerId="ADAL" clId="{891409C9-2319-433B-8001-2E1CE368518E}" dt="2025-08-18T09:57:07.527" v="0" actId="47"/>
+        <pc:sldMkLst>
+          <pc:docMk/>
+          <pc:sldMk cId="544279955" sldId="258"/>
+        </pc:sldMkLst>
+      </pc:sldChg>
+      <pc:sldChg chg="delSp modSp del mod">
+        <pc:chgData name="Jonathan Bollig" userId="8b5d0afe-f106-45e0-8c3f-fd98fa124db1" providerId="ADAL" clId="{891409C9-2319-433B-8001-2E1CE368518E}" dt="2025-08-18T13:33:56.347" v="46" actId="47"/>
+        <pc:sldMkLst>
+          <pc:docMk/>
+          <pc:sldMk cId="2169503629" sldId="259"/>
+        </pc:sldMkLst>
+      </pc:sldChg>
+      <pc:sldChg chg="add">
+        <pc:chgData name="Jonathan Bollig" userId="8b5d0afe-f106-45e0-8c3f-fd98fa124db1" providerId="ADAL" clId="{891409C9-2319-433B-8001-2E1CE368518E}" dt="2025-08-18T13:33:54.473" v="45"/>
+        <pc:sldMkLst>
+          <pc:docMk/>
+          <pc:sldMk cId="932306145" sldId="260"/>
+        </pc:sldMkLst>
+      </pc:sldChg>
+      <pc:sldChg chg="del">
+        <pc:chgData name="Jonathan Bollig" userId="8b5d0afe-f106-45e0-8c3f-fd98fa124db1" providerId="ADAL" clId="{891409C9-2319-433B-8001-2E1CE368518E}" dt="2025-08-18T09:57:07.527" v="0" actId="47"/>
+        <pc:sldMkLst>
+          <pc:docMk/>
+          <pc:sldMk cId="2533283895" sldId="260"/>
+        </pc:sldMkLst>
+      </pc:sldChg>
+      <pc:sldChg chg="del">
+        <pc:chgData name="Jonathan Bollig" userId="8b5d0afe-f106-45e0-8c3f-fd98fa124db1" providerId="ADAL" clId="{891409C9-2319-433B-8001-2E1CE368518E}" dt="2025-08-18T09:57:07.527" v="0" actId="47"/>
+        <pc:sldMkLst>
+          <pc:docMk/>
+          <pc:sldMk cId="847849653" sldId="261"/>
+        </pc:sldMkLst>
+      </pc:sldChg>
+      <pc:sldChg chg="del">
+        <pc:chgData name="Jonathan Bollig" userId="8b5d0afe-f106-45e0-8c3f-fd98fa124db1" providerId="ADAL" clId="{891409C9-2319-433B-8001-2E1CE368518E}" dt="2025-08-18T09:57:07.527" v="0" actId="47"/>
+        <pc:sldMkLst>
+          <pc:docMk/>
+          <pc:sldMk cId="1908144578" sldId="262"/>
+        </pc:sldMkLst>
+      </pc:sldChg>
+      <pc:sldChg chg="del">
+        <pc:chgData name="Jonathan Bollig" userId="8b5d0afe-f106-45e0-8c3f-fd98fa124db1" providerId="ADAL" clId="{891409C9-2319-433B-8001-2E1CE368518E}" dt="2025-08-18T09:57:07.527" v="0" actId="47"/>
+        <pc:sldMkLst>
+          <pc:docMk/>
+          <pc:sldMk cId="4076698392" sldId="263"/>
+        </pc:sldMkLst>
+      </pc:sldChg>
+      <pc:sldChg chg="del">
+        <pc:chgData name="Jonathan Bollig" userId="8b5d0afe-f106-45e0-8c3f-fd98fa124db1" providerId="ADAL" clId="{891409C9-2319-433B-8001-2E1CE368518E}" dt="2025-08-18T09:57:07.527" v="0" actId="47"/>
+        <pc:sldMkLst>
+          <pc:docMk/>
+          <pc:sldMk cId="3708449378" sldId="264"/>
+        </pc:sldMkLst>
+      </pc:sldChg>
+      <pc:sldChg chg="del">
+        <pc:chgData name="Jonathan Bollig" userId="8b5d0afe-f106-45e0-8c3f-fd98fa124db1" providerId="ADAL" clId="{891409C9-2319-433B-8001-2E1CE368518E}" dt="2025-08-18T09:57:07.527" v="0" actId="47"/>
+        <pc:sldMkLst>
+          <pc:docMk/>
+          <pc:sldMk cId="933916611" sldId="265"/>
+        </pc:sldMkLst>
+      </pc:sldChg>
+      <pc:sldChg chg="del">
+        <pc:chgData name="Jonathan Bollig" userId="8b5d0afe-f106-45e0-8c3f-fd98fa124db1" providerId="ADAL" clId="{891409C9-2319-433B-8001-2E1CE368518E}" dt="2025-08-18T09:57:07.527" v="0" actId="47"/>
+        <pc:sldMkLst>
+          <pc:docMk/>
+          <pc:sldMk cId="2117799034" sldId="266"/>
+        </pc:sldMkLst>
+      </pc:sldChg>
+    </pc:docChg>
+  </pc:docChgLst>
   <pc:docChgLst>
     <pc:chgData name="Jonathan Bollig" userId="8b5d0afe-f106-45e0-8c3f-fd98fa124db1" providerId="ADAL" clId="{B108959E-8160-4214-BA0D-42D2F1070C03}"/>
     <pc:docChg chg="undo custSel addSld modSld sldOrd">
@@ -649,99 +742,6 @@
       </pc:sldChg>
     </pc:docChg>
   </pc:docChgLst>
-  <pc:docChgLst>
-    <pc:chgData name="Jonathan Bollig" userId="8b5d0afe-f106-45e0-8c3f-fd98fa124db1" providerId="ADAL" clId="{891409C9-2319-433B-8001-2E1CE368518E}"/>
-    <pc:docChg chg="custSel addSld delSld modSld">
-      <pc:chgData name="Jonathan Bollig" userId="8b5d0afe-f106-45e0-8c3f-fd98fa124db1" providerId="ADAL" clId="{891409C9-2319-433B-8001-2E1CE368518E}" dt="2025-08-18T13:33:56.347" v="46" actId="47"/>
-      <pc:docMkLst>
-        <pc:docMk/>
-      </pc:docMkLst>
-      <pc:sldChg chg="modSp mod">
-        <pc:chgData name="Jonathan Bollig" userId="8b5d0afe-f106-45e0-8c3f-fd98fa124db1" providerId="ADAL" clId="{891409C9-2319-433B-8001-2E1CE368518E}" dt="2025-08-18T10:03:07.320" v="7" actId="20577"/>
-        <pc:sldMkLst>
-          <pc:docMk/>
-          <pc:sldMk cId="836289018" sldId="256"/>
-        </pc:sldMkLst>
-      </pc:sldChg>
-      <pc:sldChg chg="del">
-        <pc:chgData name="Jonathan Bollig" userId="8b5d0afe-f106-45e0-8c3f-fd98fa124db1" providerId="ADAL" clId="{891409C9-2319-433B-8001-2E1CE368518E}" dt="2025-08-18T09:57:07.527" v="0" actId="47"/>
-        <pc:sldMkLst>
-          <pc:docMk/>
-          <pc:sldMk cId="3656329933" sldId="257"/>
-        </pc:sldMkLst>
-      </pc:sldChg>
-      <pc:sldChg chg="del">
-        <pc:chgData name="Jonathan Bollig" userId="8b5d0afe-f106-45e0-8c3f-fd98fa124db1" providerId="ADAL" clId="{891409C9-2319-433B-8001-2E1CE368518E}" dt="2025-08-18T09:57:07.527" v="0" actId="47"/>
-        <pc:sldMkLst>
-          <pc:docMk/>
-          <pc:sldMk cId="544279955" sldId="258"/>
-        </pc:sldMkLst>
-      </pc:sldChg>
-      <pc:sldChg chg="delSp modSp del mod">
-        <pc:chgData name="Jonathan Bollig" userId="8b5d0afe-f106-45e0-8c3f-fd98fa124db1" providerId="ADAL" clId="{891409C9-2319-433B-8001-2E1CE368518E}" dt="2025-08-18T13:33:56.347" v="46" actId="47"/>
-        <pc:sldMkLst>
-          <pc:docMk/>
-          <pc:sldMk cId="2169503629" sldId="259"/>
-        </pc:sldMkLst>
-      </pc:sldChg>
-      <pc:sldChg chg="add">
-        <pc:chgData name="Jonathan Bollig" userId="8b5d0afe-f106-45e0-8c3f-fd98fa124db1" providerId="ADAL" clId="{891409C9-2319-433B-8001-2E1CE368518E}" dt="2025-08-18T13:33:54.473" v="45"/>
-        <pc:sldMkLst>
-          <pc:docMk/>
-          <pc:sldMk cId="932306145" sldId="260"/>
-        </pc:sldMkLst>
-      </pc:sldChg>
-      <pc:sldChg chg="del">
-        <pc:chgData name="Jonathan Bollig" userId="8b5d0afe-f106-45e0-8c3f-fd98fa124db1" providerId="ADAL" clId="{891409C9-2319-433B-8001-2E1CE368518E}" dt="2025-08-18T09:57:07.527" v="0" actId="47"/>
-        <pc:sldMkLst>
-          <pc:docMk/>
-          <pc:sldMk cId="2533283895" sldId="260"/>
-        </pc:sldMkLst>
-      </pc:sldChg>
-      <pc:sldChg chg="del">
-        <pc:chgData name="Jonathan Bollig" userId="8b5d0afe-f106-45e0-8c3f-fd98fa124db1" providerId="ADAL" clId="{891409C9-2319-433B-8001-2E1CE368518E}" dt="2025-08-18T09:57:07.527" v="0" actId="47"/>
-        <pc:sldMkLst>
-          <pc:docMk/>
-          <pc:sldMk cId="847849653" sldId="261"/>
-        </pc:sldMkLst>
-      </pc:sldChg>
-      <pc:sldChg chg="del">
-        <pc:chgData name="Jonathan Bollig" userId="8b5d0afe-f106-45e0-8c3f-fd98fa124db1" providerId="ADAL" clId="{891409C9-2319-433B-8001-2E1CE368518E}" dt="2025-08-18T09:57:07.527" v="0" actId="47"/>
-        <pc:sldMkLst>
-          <pc:docMk/>
-          <pc:sldMk cId="1908144578" sldId="262"/>
-        </pc:sldMkLst>
-      </pc:sldChg>
-      <pc:sldChg chg="del">
-        <pc:chgData name="Jonathan Bollig" userId="8b5d0afe-f106-45e0-8c3f-fd98fa124db1" providerId="ADAL" clId="{891409C9-2319-433B-8001-2E1CE368518E}" dt="2025-08-18T09:57:07.527" v="0" actId="47"/>
-        <pc:sldMkLst>
-          <pc:docMk/>
-          <pc:sldMk cId="4076698392" sldId="263"/>
-        </pc:sldMkLst>
-      </pc:sldChg>
-      <pc:sldChg chg="del">
-        <pc:chgData name="Jonathan Bollig" userId="8b5d0afe-f106-45e0-8c3f-fd98fa124db1" providerId="ADAL" clId="{891409C9-2319-433B-8001-2E1CE368518E}" dt="2025-08-18T09:57:07.527" v="0" actId="47"/>
-        <pc:sldMkLst>
-          <pc:docMk/>
-          <pc:sldMk cId="3708449378" sldId="264"/>
-        </pc:sldMkLst>
-      </pc:sldChg>
-      <pc:sldChg chg="del">
-        <pc:chgData name="Jonathan Bollig" userId="8b5d0afe-f106-45e0-8c3f-fd98fa124db1" providerId="ADAL" clId="{891409C9-2319-433B-8001-2E1CE368518E}" dt="2025-08-18T09:57:07.527" v="0" actId="47"/>
-        <pc:sldMkLst>
-          <pc:docMk/>
-          <pc:sldMk cId="933916611" sldId="265"/>
-        </pc:sldMkLst>
-      </pc:sldChg>
-      <pc:sldChg chg="del">
-        <pc:chgData name="Jonathan Bollig" userId="8b5d0afe-f106-45e0-8c3f-fd98fa124db1" providerId="ADAL" clId="{891409C9-2319-433B-8001-2E1CE368518E}" dt="2025-08-18T09:57:07.527" v="0" actId="47"/>
-        <pc:sldMkLst>
-          <pc:docMk/>
-          <pc:sldMk cId="2117799034" sldId="266"/>
-        </pc:sldMkLst>
-      </pc:sldChg>
-    </pc:docChg>
-  </pc:docChgLst>
 </pc:chgInfo>
 </file>
 
@@ -827,7 +827,7 @@
           <a:p>
             <a:fld id="{0B6CA2EE-5589-4682-AD7F-744DBF1E81F5}" type="datetimeFigureOut">
               <a:rPr lang="de-DE" smtClean="0"/>
-              <a:t>04.10.2025</a:t>
+              <a:t>07.10.2025</a:t>
             </a:fld>
             <a:endParaRPr lang="de-DE"/>
           </a:p>
@@ -985,7 +985,7 @@
           <a:p>
             <a:fld id="{11422C3B-6429-4381-8F08-B422F3CD22BF}" type="slidenum">
               <a:rPr lang="de-DE" smtClean="0"/>
-              <a:t>‹Nr.›</a:t>
+              <a:t>‹#›</a:t>
             </a:fld>
             <a:endParaRPr lang="de-DE"/>
           </a:p>
@@ -1094,6 +1094,90 @@
 </p:notesMaster>
 </file>
 
+<file path=ppt/notesSlides/notesSlide1.xml><?xml version="1.0" encoding="utf-8"?>
+<p:notes xmlns:a="http://schemas.openxmlformats.org/drawingml/2006/main" xmlns:r="http://schemas.openxmlformats.org/officeDocument/2006/relationships" xmlns:p="http://schemas.openxmlformats.org/presentationml/2006/main">
+  <p:cSld>
+    <p:spTree>
+      <p:nvGrpSpPr>
+        <p:cNvPr id="1" name=""/>
+        <p:cNvGrpSpPr/>
+        <p:nvPr/>
+      </p:nvGrpSpPr>
+      <p:grpSpPr>
+        <a:xfrm>
+          <a:off x="0" y="0"/>
+          <a:ext cx="0" cy="0"/>
+          <a:chOff x="0" y="0"/>
+          <a:chExt cx="0" cy="0"/>
+        </a:xfrm>
+      </p:grpSpPr>
+      <p:sp>
+        <p:nvSpPr>
+          <p:cNvPr id="2" name="Slide Image Placeholder 1"/>
+          <p:cNvSpPr>
+            <a:spLocks noGrp="1" noRot="1" noChangeAspect="1"/>
+          </p:cNvSpPr>
+          <p:nvPr>
+            <p:ph type="sldImg"/>
+          </p:nvPr>
+        </p:nvSpPr>
+        <p:spPr/>
+      </p:sp>
+      <p:sp>
+        <p:nvSpPr>
+          <p:cNvPr id="3" name="Notes Placeholder 2"/>
+          <p:cNvSpPr>
+            <a:spLocks noGrp="1"/>
+          </p:cNvSpPr>
+          <p:nvPr>
+            <p:ph type="body" idx="1"/>
+          </p:nvPr>
+        </p:nvSpPr>
+        <p:spPr/>
+        <p:txBody>
+          <a:bodyPr/>
+          <a:lstStyle/>
+          <a:p>
+            <a:endParaRPr lang="de-DE" dirty="0"/>
+          </a:p>
+        </p:txBody>
+      </p:sp>
+      <p:sp>
+        <p:nvSpPr>
+          <p:cNvPr id="4" name="Slide Number Placeholder 3"/>
+          <p:cNvSpPr>
+            <a:spLocks noGrp="1"/>
+          </p:cNvSpPr>
+          <p:nvPr>
+            <p:ph type="sldNum" sz="quarter" idx="5"/>
+          </p:nvPr>
+        </p:nvSpPr>
+        <p:spPr/>
+        <p:txBody>
+          <a:bodyPr/>
+          <a:lstStyle/>
+          <a:p>
+            <a:fld id="{11422C3B-6429-4381-8F08-B422F3CD22BF}" type="slidenum">
+              <a:rPr lang="de-DE" smtClean="0"/>
+              <a:t>8</a:t>
+            </a:fld>
+            <a:endParaRPr lang="de-DE"/>
+          </a:p>
+        </p:txBody>
+      </p:sp>
+    </p:spTree>
+    <p:extLst>
+      <p:ext uri="{BB962C8B-B14F-4D97-AF65-F5344CB8AC3E}">
+        <p14:creationId xmlns:p14="http://schemas.microsoft.com/office/powerpoint/2010/main" val="1849325965"/>
+      </p:ext>
+    </p:extLst>
+  </p:cSld>
+  <p:clrMapOvr>
+    <a:masterClrMapping/>
+  </p:clrMapOvr>
+</p:notes>
+</file>
+
 <file path=ppt/slideLayouts/slideLayout1.xml><?xml version="1.0" encoding="utf-8"?>
 <p:sldLayout xmlns:a="http://schemas.openxmlformats.org/drawingml/2006/main" xmlns:r="http://schemas.openxmlformats.org/officeDocument/2006/relationships" xmlns:p="http://schemas.openxmlformats.org/presentationml/2006/main" type="title" preserve="1">
   <p:cSld name="Titelfolie">
@@ -1241,7 +1325,7 @@
           <a:p>
             <a:fld id="{ADA51F25-4808-47F4-BF6E-BCDC230DB01C}" type="datetimeFigureOut">
               <a:rPr lang="de-DE" smtClean="0"/>
-              <a:t>04.10.2025</a:t>
+              <a:t>07.10.2025</a:t>
             </a:fld>
             <a:endParaRPr lang="de-DE"/>
           </a:p>
@@ -1295,7 +1379,7 @@
           <a:p>
             <a:fld id="{C018A060-D51C-4243-8F88-61D66D5570B8}" type="slidenum">
               <a:rPr lang="de-DE" smtClean="0"/>
-              <a:t>‹Nr.›</a:t>
+              <a:t>‹#›</a:t>
             </a:fld>
             <a:endParaRPr lang="de-DE"/>
           </a:p>
@@ -1439,7 +1523,7 @@
           <a:p>
             <a:fld id="{ADA51F25-4808-47F4-BF6E-BCDC230DB01C}" type="datetimeFigureOut">
               <a:rPr lang="de-DE" smtClean="0"/>
-              <a:t>04.10.2025</a:t>
+              <a:t>07.10.2025</a:t>
             </a:fld>
             <a:endParaRPr lang="de-DE"/>
           </a:p>
@@ -1493,7 +1577,7 @@
           <a:p>
             <a:fld id="{C018A060-D51C-4243-8F88-61D66D5570B8}" type="slidenum">
               <a:rPr lang="de-DE" smtClean="0"/>
-              <a:t>‹Nr.›</a:t>
+              <a:t>‹#›</a:t>
             </a:fld>
             <a:endParaRPr lang="de-DE"/>
           </a:p>
@@ -1647,7 +1731,7 @@
           <a:p>
             <a:fld id="{ADA51F25-4808-47F4-BF6E-BCDC230DB01C}" type="datetimeFigureOut">
               <a:rPr lang="de-DE" smtClean="0"/>
-              <a:t>04.10.2025</a:t>
+              <a:t>07.10.2025</a:t>
             </a:fld>
             <a:endParaRPr lang="de-DE"/>
           </a:p>
@@ -1701,7 +1785,7 @@
           <a:p>
             <a:fld id="{C018A060-D51C-4243-8F88-61D66D5570B8}" type="slidenum">
               <a:rPr lang="de-DE" smtClean="0"/>
-              <a:t>‹Nr.›</a:t>
+              <a:t>‹#›</a:t>
             </a:fld>
             <a:endParaRPr lang="de-DE"/>
           </a:p>
@@ -1845,7 +1929,7 @@
           <a:p>
             <a:fld id="{ADA51F25-4808-47F4-BF6E-BCDC230DB01C}" type="datetimeFigureOut">
               <a:rPr lang="de-DE" smtClean="0"/>
-              <a:t>04.10.2025</a:t>
+              <a:t>07.10.2025</a:t>
             </a:fld>
             <a:endParaRPr lang="de-DE"/>
           </a:p>
@@ -1899,7 +1983,7 @@
           <a:p>
             <a:fld id="{C018A060-D51C-4243-8F88-61D66D5570B8}" type="slidenum">
               <a:rPr lang="de-DE" smtClean="0"/>
-              <a:t>‹Nr.›</a:t>
+              <a:t>‹#›</a:t>
             </a:fld>
             <a:endParaRPr lang="de-DE"/>
           </a:p>
@@ -2120,7 +2204,7 @@
           <a:p>
             <a:fld id="{ADA51F25-4808-47F4-BF6E-BCDC230DB01C}" type="datetimeFigureOut">
               <a:rPr lang="de-DE" smtClean="0"/>
-              <a:t>04.10.2025</a:t>
+              <a:t>07.10.2025</a:t>
             </a:fld>
             <a:endParaRPr lang="de-DE"/>
           </a:p>
@@ -2174,7 +2258,7 @@
           <a:p>
             <a:fld id="{C018A060-D51C-4243-8F88-61D66D5570B8}" type="slidenum">
               <a:rPr lang="de-DE" smtClean="0"/>
-              <a:t>‹Nr.›</a:t>
+              <a:t>‹#›</a:t>
             </a:fld>
             <a:endParaRPr lang="de-DE"/>
           </a:p>
@@ -2385,7 +2469,7 @@
           <a:p>
             <a:fld id="{ADA51F25-4808-47F4-BF6E-BCDC230DB01C}" type="datetimeFigureOut">
               <a:rPr lang="de-DE" smtClean="0"/>
-              <a:t>04.10.2025</a:t>
+              <a:t>07.10.2025</a:t>
             </a:fld>
             <a:endParaRPr lang="de-DE"/>
           </a:p>
@@ -2439,7 +2523,7 @@
           <a:p>
             <a:fld id="{C018A060-D51C-4243-8F88-61D66D5570B8}" type="slidenum">
               <a:rPr lang="de-DE" smtClean="0"/>
-              <a:t>‹Nr.›</a:t>
+              <a:t>‹#›</a:t>
             </a:fld>
             <a:endParaRPr lang="de-DE"/>
           </a:p>
@@ -2797,7 +2881,7 @@
           <a:p>
             <a:fld id="{ADA51F25-4808-47F4-BF6E-BCDC230DB01C}" type="datetimeFigureOut">
               <a:rPr lang="de-DE" smtClean="0"/>
-              <a:t>04.10.2025</a:t>
+              <a:t>07.10.2025</a:t>
             </a:fld>
             <a:endParaRPr lang="de-DE"/>
           </a:p>
@@ -2851,7 +2935,7 @@
           <a:p>
             <a:fld id="{C018A060-D51C-4243-8F88-61D66D5570B8}" type="slidenum">
               <a:rPr lang="de-DE" smtClean="0"/>
-              <a:t>‹Nr.›</a:t>
+              <a:t>‹#›</a:t>
             </a:fld>
             <a:endParaRPr lang="de-DE"/>
           </a:p>
@@ -2938,7 +3022,7 @@
           <a:p>
             <a:fld id="{ADA51F25-4808-47F4-BF6E-BCDC230DB01C}" type="datetimeFigureOut">
               <a:rPr lang="de-DE" smtClean="0"/>
-              <a:t>04.10.2025</a:t>
+              <a:t>07.10.2025</a:t>
             </a:fld>
             <a:endParaRPr lang="de-DE"/>
           </a:p>
@@ -2992,7 +3076,7 @@
           <a:p>
             <a:fld id="{C018A060-D51C-4243-8F88-61D66D5570B8}" type="slidenum">
               <a:rPr lang="de-DE" smtClean="0"/>
-              <a:t>‹Nr.›</a:t>
+              <a:t>‹#›</a:t>
             </a:fld>
             <a:endParaRPr lang="de-DE"/>
           </a:p>
@@ -3051,7 +3135,7 @@
           <a:p>
             <a:fld id="{ADA51F25-4808-47F4-BF6E-BCDC230DB01C}" type="datetimeFigureOut">
               <a:rPr lang="de-DE" smtClean="0"/>
-              <a:t>04.10.2025</a:t>
+              <a:t>07.10.2025</a:t>
             </a:fld>
             <a:endParaRPr lang="de-DE"/>
           </a:p>
@@ -3105,7 +3189,7 @@
           <a:p>
             <a:fld id="{C018A060-D51C-4243-8F88-61D66D5570B8}" type="slidenum">
               <a:rPr lang="de-DE" smtClean="0"/>
-              <a:t>‹Nr.›</a:t>
+              <a:t>‹#›</a:t>
             </a:fld>
             <a:endParaRPr lang="de-DE"/>
           </a:p>
@@ -3362,7 +3446,7 @@
           <a:p>
             <a:fld id="{ADA51F25-4808-47F4-BF6E-BCDC230DB01C}" type="datetimeFigureOut">
               <a:rPr lang="de-DE" smtClean="0"/>
-              <a:t>04.10.2025</a:t>
+              <a:t>07.10.2025</a:t>
             </a:fld>
             <a:endParaRPr lang="de-DE"/>
           </a:p>
@@ -3416,7 +3500,7 @@
           <a:p>
             <a:fld id="{C018A060-D51C-4243-8F88-61D66D5570B8}" type="slidenum">
               <a:rPr lang="de-DE" smtClean="0"/>
-              <a:t>‹Nr.›</a:t>
+              <a:t>‹#›</a:t>
             </a:fld>
             <a:endParaRPr lang="de-DE"/>
           </a:p>
@@ -3650,7 +3734,7 @@
           <a:p>
             <a:fld id="{ADA51F25-4808-47F4-BF6E-BCDC230DB01C}" type="datetimeFigureOut">
               <a:rPr lang="de-DE" smtClean="0"/>
-              <a:t>04.10.2025</a:t>
+              <a:t>07.10.2025</a:t>
             </a:fld>
             <a:endParaRPr lang="de-DE"/>
           </a:p>
@@ -3704,7 +3788,7 @@
           <a:p>
             <a:fld id="{C018A060-D51C-4243-8F88-61D66D5570B8}" type="slidenum">
               <a:rPr lang="de-DE" smtClean="0"/>
-              <a:t>‹Nr.›</a:t>
+              <a:t>‹#›</a:t>
             </a:fld>
             <a:endParaRPr lang="de-DE"/>
           </a:p>
@@ -3891,7 +3975,7 @@
           <a:p>
             <a:fld id="{ADA51F25-4808-47F4-BF6E-BCDC230DB01C}" type="datetimeFigureOut">
               <a:rPr lang="de-DE" smtClean="0"/>
-              <a:t>04.10.2025</a:t>
+              <a:t>07.10.2025</a:t>
             </a:fld>
             <a:endParaRPr lang="de-DE"/>
           </a:p>
@@ -3981,7 +4065,7 @@
           <a:p>
             <a:fld id="{C018A060-D51C-4243-8F88-61D66D5570B8}" type="slidenum">
               <a:rPr lang="de-DE" smtClean="0"/>
-              <a:t>‹Nr.›</a:t>
+              <a:t>‹#›</a:t>
             </a:fld>
             <a:endParaRPr lang="de-DE"/>
           </a:p>
@@ -4324,7 +4408,12 @@
             <p:ph type="ctrTitle"/>
           </p:nvPr>
         </p:nvSpPr>
-        <p:spPr/>
+        <p:spPr>
+          <a:xfrm>
+            <a:off x="1524000" y="1747396"/>
+            <a:ext cx="9144000" cy="2387600"/>
+          </a:xfrm>
+        </p:spPr>
         <p:txBody>
           <a:bodyPr>
             <a:normAutofit fontScale="90000"/>
@@ -4343,23 +4432,14 @@
               <a:t>(And everyone else!)</a:t>
             </a:r>
             <a:br>
+              <a:rPr lang="en-US" dirty="0"/>
+            </a:br>
+            <a:br>
               <a:rPr lang="en-US" noProof="0" dirty="0"/>
             </a:br>
             <a:r>
-              <a:rPr lang="en-US" noProof="0"/>
-              <a:t>Chunk </a:t>
-            </a:r>
-            <a:r>
-              <a:rPr lang="en-US" noProof="0" dirty="0"/>
-              <a:t>4</a:t>
-            </a:r>
-            <a:r>
-              <a:rPr lang="en-US" noProof="0"/>
-              <a:t>: </a:t>
-            </a:r>
-            <a:r>
-              <a:rPr lang="en-US" noProof="0" dirty="0"/>
-              <a:t>Lists and Tuples</a:t>
+              <a:rPr lang="en-US" b="1" noProof="0" dirty="0"/>
+              <a:t>Chunk 4: Lists and Tuples</a:t>
             </a:r>
           </a:p>
         </p:txBody>
@@ -4380,7 +4460,12 @@
             <p:ph type="subTitle" idx="1"/>
           </p:nvPr>
         </p:nvSpPr>
-        <p:spPr/>
+        <p:spPr>
+          <a:xfrm>
+            <a:off x="1524000" y="4551162"/>
+            <a:ext cx="9144000" cy="1655762"/>
+          </a:xfrm>
+        </p:spPr>
         <p:txBody>
           <a:bodyPr/>
           <a:lstStyle/>
@@ -4446,7 +4531,7 @@
         </p:nvSpPr>
         <p:spPr>
           <a:xfrm>
-            <a:off x="838200" y="1647031"/>
+            <a:off x="838200" y="918914"/>
             <a:ext cx="10515600" cy="1325563"/>
           </a:xfrm>
         </p:spPr>
@@ -4491,7 +4576,7 @@
         </p:blipFill>
         <p:spPr>
           <a:xfrm>
-            <a:off x="4270248" y="2831592"/>
+            <a:off x="4142926" y="2287582"/>
             <a:ext cx="3651504" cy="3651504"/>
           </a:xfrm>
           <a:prstGeom prst="rect">
@@ -4513,7 +4598,7 @@
         </p:nvSpPr>
         <p:spPr>
           <a:xfrm>
-            <a:off x="4402588" y="6483096"/>
+            <a:off x="4275266" y="5939086"/>
             <a:ext cx="5168851" cy="276999"/>
           </a:xfrm>
           <a:prstGeom prst="rect">
@@ -4930,6 +5015,264 @@
   <p:clrMapOvr>
     <a:masterClrMapping/>
   </p:clrMapOvr>
+  <p:timing>
+    <p:tnLst>
+      <p:par>
+        <p:cTn id="1" dur="indefinite" restart="never" nodeType="tmRoot">
+          <p:childTnLst>
+            <p:seq concurrent="1" nextAc="seek">
+              <p:cTn id="2" dur="indefinite" nodeType="mainSeq">
+                <p:childTnLst>
+                  <p:par>
+                    <p:cTn id="3" fill="hold">
+                      <p:stCondLst>
+                        <p:cond delay="indefinite"/>
+                      </p:stCondLst>
+                      <p:childTnLst>
+                        <p:par>
+                          <p:cTn id="4" fill="hold">
+                            <p:stCondLst>
+                              <p:cond delay="0"/>
+                            </p:stCondLst>
+                            <p:childTnLst>
+                              <p:par>
+                                <p:cTn id="5" presetID="1" presetClass="entr" presetSubtype="0" fill="hold" nodeType="clickEffect">
+                                  <p:stCondLst>
+                                    <p:cond delay="0"/>
+                                  </p:stCondLst>
+                                  <p:childTnLst>
+                                    <p:set>
+                                      <p:cBhvr>
+                                        <p:cTn id="6" dur="1" fill="hold">
+                                          <p:stCondLst>
+                                            <p:cond delay="0"/>
+                                          </p:stCondLst>
+                                        </p:cTn>
+                                        <p:tgtEl>
+                                          <p:spTgt spid="3">
+                                            <p:txEl>
+                                              <p:pRg st="2" end="2"/>
+                                            </p:txEl>
+                                          </p:spTgt>
+                                        </p:tgtEl>
+                                        <p:attrNameLst>
+                                          <p:attrName>style.visibility</p:attrName>
+                                        </p:attrNameLst>
+                                      </p:cBhvr>
+                                      <p:to>
+                                        <p:strVal val="visible"/>
+                                      </p:to>
+                                    </p:set>
+                                  </p:childTnLst>
+                                </p:cTn>
+                              </p:par>
+                              <p:par>
+                                <p:cTn id="7" presetID="1" presetClass="entr" presetSubtype="0" fill="hold" nodeType="withEffect">
+                                  <p:stCondLst>
+                                    <p:cond delay="0"/>
+                                  </p:stCondLst>
+                                  <p:childTnLst>
+                                    <p:set>
+                                      <p:cBhvr>
+                                        <p:cTn id="8" dur="1" fill="hold">
+                                          <p:stCondLst>
+                                            <p:cond delay="0"/>
+                                          </p:stCondLst>
+                                        </p:cTn>
+                                        <p:tgtEl>
+                                          <p:spTgt spid="7"/>
+                                        </p:tgtEl>
+                                        <p:attrNameLst>
+                                          <p:attrName>style.visibility</p:attrName>
+                                        </p:attrNameLst>
+                                      </p:cBhvr>
+                                      <p:to>
+                                        <p:strVal val="visible"/>
+                                      </p:to>
+                                    </p:set>
+                                  </p:childTnLst>
+                                </p:cTn>
+                              </p:par>
+                            </p:childTnLst>
+                          </p:cTn>
+                        </p:par>
+                      </p:childTnLst>
+                    </p:cTn>
+                  </p:par>
+                  <p:par>
+                    <p:cTn id="9" fill="hold">
+                      <p:stCondLst>
+                        <p:cond delay="indefinite"/>
+                      </p:stCondLst>
+                      <p:childTnLst>
+                        <p:par>
+                          <p:cTn id="10" fill="hold">
+                            <p:stCondLst>
+                              <p:cond delay="0"/>
+                            </p:stCondLst>
+                            <p:childTnLst>
+                              <p:par>
+                                <p:cTn id="11" presetID="1" presetClass="entr" presetSubtype="0" fill="hold" nodeType="clickEffect">
+                                  <p:stCondLst>
+                                    <p:cond delay="0"/>
+                                  </p:stCondLst>
+                                  <p:childTnLst>
+                                    <p:set>
+                                      <p:cBhvr>
+                                        <p:cTn id="12" dur="1" fill="hold">
+                                          <p:stCondLst>
+                                            <p:cond delay="0"/>
+                                          </p:stCondLst>
+                                        </p:cTn>
+                                        <p:tgtEl>
+                                          <p:spTgt spid="3">
+                                            <p:txEl>
+                                              <p:pRg st="3" end="3"/>
+                                            </p:txEl>
+                                          </p:spTgt>
+                                        </p:tgtEl>
+                                        <p:attrNameLst>
+                                          <p:attrName>style.visibility</p:attrName>
+                                        </p:attrNameLst>
+                                      </p:cBhvr>
+                                      <p:to>
+                                        <p:strVal val="visible"/>
+                                      </p:to>
+                                    </p:set>
+                                  </p:childTnLst>
+                                </p:cTn>
+                              </p:par>
+                              <p:par>
+                                <p:cTn id="13" presetID="1" presetClass="entr" presetSubtype="0" fill="hold" nodeType="withEffect">
+                                  <p:stCondLst>
+                                    <p:cond delay="0"/>
+                                  </p:stCondLst>
+                                  <p:childTnLst>
+                                    <p:set>
+                                      <p:cBhvr>
+                                        <p:cTn id="14" dur="1" fill="hold">
+                                          <p:stCondLst>
+                                            <p:cond delay="0"/>
+                                          </p:stCondLst>
+                                        </p:cTn>
+                                        <p:tgtEl>
+                                          <p:spTgt spid="9"/>
+                                        </p:tgtEl>
+                                        <p:attrNameLst>
+                                          <p:attrName>style.visibility</p:attrName>
+                                        </p:attrNameLst>
+                                      </p:cBhvr>
+                                      <p:to>
+                                        <p:strVal val="visible"/>
+                                      </p:to>
+                                    </p:set>
+                                  </p:childTnLst>
+                                </p:cTn>
+                              </p:par>
+                            </p:childTnLst>
+                          </p:cTn>
+                        </p:par>
+                      </p:childTnLst>
+                    </p:cTn>
+                  </p:par>
+                  <p:par>
+                    <p:cTn id="15" fill="hold">
+                      <p:stCondLst>
+                        <p:cond delay="indefinite"/>
+                      </p:stCondLst>
+                      <p:childTnLst>
+                        <p:par>
+                          <p:cTn id="16" fill="hold">
+                            <p:stCondLst>
+                              <p:cond delay="0"/>
+                            </p:stCondLst>
+                            <p:childTnLst>
+                              <p:par>
+                                <p:cTn id="17" presetID="1" presetClass="entr" presetSubtype="0" fill="hold" nodeType="clickEffect">
+                                  <p:stCondLst>
+                                    <p:cond delay="0"/>
+                                  </p:stCondLst>
+                                  <p:childTnLst>
+                                    <p:set>
+                                      <p:cBhvr>
+                                        <p:cTn id="18" dur="1" fill="hold">
+                                          <p:stCondLst>
+                                            <p:cond delay="0"/>
+                                          </p:stCondLst>
+                                        </p:cTn>
+                                        <p:tgtEl>
+                                          <p:spTgt spid="3">
+                                            <p:txEl>
+                                              <p:pRg st="5" end="5"/>
+                                            </p:txEl>
+                                          </p:spTgt>
+                                        </p:tgtEl>
+                                        <p:attrNameLst>
+                                          <p:attrName>style.visibility</p:attrName>
+                                        </p:attrNameLst>
+                                      </p:cBhvr>
+                                      <p:to>
+                                        <p:strVal val="visible"/>
+                                      </p:to>
+                                    </p:set>
+                                  </p:childTnLst>
+                                </p:cTn>
+                              </p:par>
+                              <p:par>
+                                <p:cTn id="19" presetID="1" presetClass="entr" presetSubtype="0" fill="hold" nodeType="withEffect">
+                                  <p:stCondLst>
+                                    <p:cond delay="0"/>
+                                  </p:stCondLst>
+                                  <p:childTnLst>
+                                    <p:set>
+                                      <p:cBhvr>
+                                        <p:cTn id="20" dur="1" fill="hold">
+                                          <p:stCondLst>
+                                            <p:cond delay="0"/>
+                                          </p:stCondLst>
+                                        </p:cTn>
+                                        <p:tgtEl>
+                                          <p:spTgt spid="11"/>
+                                        </p:tgtEl>
+                                        <p:attrNameLst>
+                                          <p:attrName>style.visibility</p:attrName>
+                                        </p:attrNameLst>
+                                      </p:cBhvr>
+                                      <p:to>
+                                        <p:strVal val="visible"/>
+                                      </p:to>
+                                    </p:set>
+                                  </p:childTnLst>
+                                </p:cTn>
+                              </p:par>
+                            </p:childTnLst>
+                          </p:cTn>
+                        </p:par>
+                      </p:childTnLst>
+                    </p:cTn>
+                  </p:par>
+                </p:childTnLst>
+              </p:cTn>
+              <p:prevCondLst>
+                <p:cond evt="onPrev" delay="0">
+                  <p:tgtEl>
+                    <p:sldTgt/>
+                  </p:tgtEl>
+                </p:cond>
+              </p:prevCondLst>
+              <p:nextCondLst>
+                <p:cond evt="onNext" delay="0">
+                  <p:tgtEl>
+                    <p:sldTgt/>
+                  </p:tgtEl>
+                </p:cond>
+              </p:nextCondLst>
+            </p:seq>
+          </p:childTnLst>
+        </p:cTn>
+      </p:par>
+    </p:tnLst>
+  </p:timing>
 </p:sld>
 </file>
 
@@ -5028,7 +5371,7 @@
               <a:rPr lang="en-US" dirty="0">
                 <a:sym typeface="Wingdings" panose="05000000000000000000" pitchFamily="2" charset="2"/>
               </a:rPr>
-              <a:t>0 – Indexed!</a:t>
+              <a:t> 0 – Indexed!</a:t>
             </a:r>
             <a:endParaRPr lang="en-US" dirty="0"/>
           </a:p>
@@ -5054,7 +5397,7 @@
               <a:rPr lang="en-US" dirty="0">
                 <a:sym typeface="Wingdings" panose="05000000000000000000" pitchFamily="2" charset="2"/>
               </a:rPr>
-              <a:t>1 – Indexed!</a:t>
+              <a:t> 1 – Indexed!</a:t>
             </a:r>
             <a:endParaRPr lang="en-US" dirty="0"/>
           </a:p>
@@ -5115,7 +5458,7 @@
               <a:rPr lang="en-US" dirty="0">
                 <a:sym typeface="Wingdings" panose="05000000000000000000" pitchFamily="2" charset="2"/>
               </a:rPr>
-              <a:t>Start is inclusive</a:t>
+              <a:t> Start is inclusive</a:t>
             </a:r>
           </a:p>
           <a:p>
@@ -5126,7 +5469,7 @@
               <a:rPr lang="en-US" dirty="0">
                 <a:sym typeface="Wingdings" panose="05000000000000000000" pitchFamily="2" charset="2"/>
               </a:rPr>
-              <a:t>End is exclusive</a:t>
+              <a:t> End is exclusive</a:t>
             </a:r>
             <a:endParaRPr lang="en-US" dirty="0"/>
           </a:p>
@@ -5387,6 +5730,464 @@
   <p:clrMapOvr>
     <a:masterClrMapping/>
   </p:clrMapOvr>
+  <p:timing>
+    <p:tnLst>
+      <p:par>
+        <p:cTn id="1" dur="indefinite" restart="never" nodeType="tmRoot">
+          <p:childTnLst>
+            <p:seq concurrent="1" nextAc="seek">
+              <p:cTn id="2" dur="indefinite" nodeType="mainSeq">
+                <p:childTnLst>
+                  <p:par>
+                    <p:cTn id="3" fill="hold">
+                      <p:stCondLst>
+                        <p:cond delay="indefinite"/>
+                      </p:stCondLst>
+                      <p:childTnLst>
+                        <p:par>
+                          <p:cTn id="4" fill="hold">
+                            <p:stCondLst>
+                              <p:cond delay="0"/>
+                            </p:stCondLst>
+                            <p:childTnLst>
+                              <p:par>
+                                <p:cTn id="5" presetID="1" presetClass="entr" presetSubtype="0" fill="hold" nodeType="clickEffect">
+                                  <p:stCondLst>
+                                    <p:cond delay="0"/>
+                                  </p:stCondLst>
+                                  <p:childTnLst>
+                                    <p:set>
+                                      <p:cBhvr>
+                                        <p:cTn id="6" dur="1" fill="hold">
+                                          <p:stCondLst>
+                                            <p:cond delay="0"/>
+                                          </p:stCondLst>
+                                        </p:cTn>
+                                        <p:tgtEl>
+                                          <p:spTgt spid="3">
+                                            <p:txEl>
+                                              <p:pRg st="0" end="0"/>
+                                            </p:txEl>
+                                          </p:spTgt>
+                                        </p:tgtEl>
+                                        <p:attrNameLst>
+                                          <p:attrName>style.visibility</p:attrName>
+                                        </p:attrNameLst>
+                                      </p:cBhvr>
+                                      <p:to>
+                                        <p:strVal val="visible"/>
+                                      </p:to>
+                                    </p:set>
+                                  </p:childTnLst>
+                                </p:cTn>
+                              </p:par>
+                              <p:par>
+                                <p:cTn id="7" presetID="1" presetClass="entr" presetSubtype="0" fill="hold" nodeType="withEffect">
+                                  <p:stCondLst>
+                                    <p:cond delay="0"/>
+                                  </p:stCondLst>
+                                  <p:childTnLst>
+                                    <p:set>
+                                      <p:cBhvr>
+                                        <p:cTn id="8" dur="1" fill="hold">
+                                          <p:stCondLst>
+                                            <p:cond delay="0"/>
+                                          </p:stCondLst>
+                                        </p:cTn>
+                                        <p:tgtEl>
+                                          <p:spTgt spid="3">
+                                            <p:txEl>
+                                              <p:pRg st="1" end="1"/>
+                                            </p:txEl>
+                                          </p:spTgt>
+                                        </p:tgtEl>
+                                        <p:attrNameLst>
+                                          <p:attrName>style.visibility</p:attrName>
+                                        </p:attrNameLst>
+                                      </p:cBhvr>
+                                      <p:to>
+                                        <p:strVal val="visible"/>
+                                      </p:to>
+                                    </p:set>
+                                  </p:childTnLst>
+                                </p:cTn>
+                              </p:par>
+                              <p:par>
+                                <p:cTn id="9" presetID="1" presetClass="entr" presetSubtype="0" fill="hold" nodeType="withEffect">
+                                  <p:stCondLst>
+                                    <p:cond delay="0"/>
+                                  </p:stCondLst>
+                                  <p:childTnLst>
+                                    <p:set>
+                                      <p:cBhvr>
+                                        <p:cTn id="10" dur="1" fill="hold">
+                                          <p:stCondLst>
+                                            <p:cond delay="0"/>
+                                          </p:stCondLst>
+                                        </p:cTn>
+                                        <p:tgtEl>
+                                          <p:spTgt spid="7"/>
+                                        </p:tgtEl>
+                                        <p:attrNameLst>
+                                          <p:attrName>style.visibility</p:attrName>
+                                        </p:attrNameLst>
+                                      </p:cBhvr>
+                                      <p:to>
+                                        <p:strVal val="visible"/>
+                                      </p:to>
+                                    </p:set>
+                                  </p:childTnLst>
+                                </p:cTn>
+                              </p:par>
+                            </p:childTnLst>
+                          </p:cTn>
+                        </p:par>
+                      </p:childTnLst>
+                    </p:cTn>
+                  </p:par>
+                  <p:par>
+                    <p:cTn id="11" fill="hold">
+                      <p:stCondLst>
+                        <p:cond delay="indefinite"/>
+                      </p:stCondLst>
+                      <p:childTnLst>
+                        <p:par>
+                          <p:cTn id="12" fill="hold">
+                            <p:stCondLst>
+                              <p:cond delay="0"/>
+                            </p:stCondLst>
+                            <p:childTnLst>
+                              <p:par>
+                                <p:cTn id="13" presetID="1" presetClass="entr" presetSubtype="0" fill="hold" nodeType="clickEffect">
+                                  <p:stCondLst>
+                                    <p:cond delay="0"/>
+                                  </p:stCondLst>
+                                  <p:childTnLst>
+                                    <p:set>
+                                      <p:cBhvr>
+                                        <p:cTn id="14" dur="1" fill="hold">
+                                          <p:stCondLst>
+                                            <p:cond delay="0"/>
+                                          </p:stCondLst>
+                                        </p:cTn>
+                                        <p:tgtEl>
+                                          <p:spTgt spid="3">
+                                            <p:txEl>
+                                              <p:pRg st="2" end="2"/>
+                                            </p:txEl>
+                                          </p:spTgt>
+                                        </p:tgtEl>
+                                        <p:attrNameLst>
+                                          <p:attrName>style.visibility</p:attrName>
+                                        </p:attrNameLst>
+                                      </p:cBhvr>
+                                      <p:to>
+                                        <p:strVal val="visible"/>
+                                      </p:to>
+                                    </p:set>
+                                  </p:childTnLst>
+                                </p:cTn>
+                              </p:par>
+                              <p:par>
+                                <p:cTn id="15" presetID="1" presetClass="entr" presetSubtype="0" fill="hold" nodeType="withEffect">
+                                  <p:stCondLst>
+                                    <p:cond delay="0"/>
+                                  </p:stCondLst>
+                                  <p:childTnLst>
+                                    <p:set>
+                                      <p:cBhvr>
+                                        <p:cTn id="16" dur="1" fill="hold">
+                                          <p:stCondLst>
+                                            <p:cond delay="0"/>
+                                          </p:stCondLst>
+                                        </p:cTn>
+                                        <p:tgtEl>
+                                          <p:spTgt spid="3">
+                                            <p:txEl>
+                                              <p:pRg st="3" end="3"/>
+                                            </p:txEl>
+                                          </p:spTgt>
+                                        </p:tgtEl>
+                                        <p:attrNameLst>
+                                          <p:attrName>style.visibility</p:attrName>
+                                        </p:attrNameLst>
+                                      </p:cBhvr>
+                                      <p:to>
+                                        <p:strVal val="visible"/>
+                                      </p:to>
+                                    </p:set>
+                                  </p:childTnLst>
+                                </p:cTn>
+                              </p:par>
+                              <p:par>
+                                <p:cTn id="17" presetID="1" presetClass="entr" presetSubtype="0" fill="hold" nodeType="withEffect">
+                                  <p:stCondLst>
+                                    <p:cond delay="0"/>
+                                  </p:stCondLst>
+                                  <p:childTnLst>
+                                    <p:set>
+                                      <p:cBhvr>
+                                        <p:cTn id="18" dur="1" fill="hold">
+                                          <p:stCondLst>
+                                            <p:cond delay="0"/>
+                                          </p:stCondLst>
+                                        </p:cTn>
+                                        <p:tgtEl>
+                                          <p:spTgt spid="9"/>
+                                        </p:tgtEl>
+                                        <p:attrNameLst>
+                                          <p:attrName>style.visibility</p:attrName>
+                                        </p:attrNameLst>
+                                      </p:cBhvr>
+                                      <p:to>
+                                        <p:strVal val="visible"/>
+                                      </p:to>
+                                    </p:set>
+                                  </p:childTnLst>
+                                </p:cTn>
+                              </p:par>
+                            </p:childTnLst>
+                          </p:cTn>
+                        </p:par>
+                      </p:childTnLst>
+                    </p:cTn>
+                  </p:par>
+                  <p:par>
+                    <p:cTn id="19" fill="hold">
+                      <p:stCondLst>
+                        <p:cond delay="indefinite"/>
+                      </p:stCondLst>
+                      <p:childTnLst>
+                        <p:par>
+                          <p:cTn id="20" fill="hold">
+                            <p:stCondLst>
+                              <p:cond delay="0"/>
+                            </p:stCondLst>
+                            <p:childTnLst>
+                              <p:par>
+                                <p:cTn id="21" presetID="1" presetClass="entr" presetSubtype="0" fill="hold" nodeType="clickEffect">
+                                  <p:stCondLst>
+                                    <p:cond delay="0"/>
+                                  </p:stCondLst>
+                                  <p:childTnLst>
+                                    <p:set>
+                                      <p:cBhvr>
+                                        <p:cTn id="22" dur="1" fill="hold">
+                                          <p:stCondLst>
+                                            <p:cond delay="0"/>
+                                          </p:stCondLst>
+                                        </p:cTn>
+                                        <p:tgtEl>
+                                          <p:spTgt spid="3">
+                                            <p:txEl>
+                                              <p:pRg st="4" end="4"/>
+                                            </p:txEl>
+                                          </p:spTgt>
+                                        </p:tgtEl>
+                                        <p:attrNameLst>
+                                          <p:attrName>style.visibility</p:attrName>
+                                        </p:attrNameLst>
+                                      </p:cBhvr>
+                                      <p:to>
+                                        <p:strVal val="visible"/>
+                                      </p:to>
+                                    </p:set>
+                                  </p:childTnLst>
+                                </p:cTn>
+                              </p:par>
+                              <p:par>
+                                <p:cTn id="23" presetID="1" presetClass="entr" presetSubtype="0" fill="hold" nodeType="withEffect">
+                                  <p:stCondLst>
+                                    <p:cond delay="0"/>
+                                  </p:stCondLst>
+                                  <p:childTnLst>
+                                    <p:set>
+                                      <p:cBhvr>
+                                        <p:cTn id="24" dur="1" fill="hold">
+                                          <p:stCondLst>
+                                            <p:cond delay="0"/>
+                                          </p:stCondLst>
+                                        </p:cTn>
+                                        <p:tgtEl>
+                                          <p:spTgt spid="3">
+                                            <p:txEl>
+                                              <p:pRg st="5" end="5"/>
+                                            </p:txEl>
+                                          </p:spTgt>
+                                        </p:tgtEl>
+                                        <p:attrNameLst>
+                                          <p:attrName>style.visibility</p:attrName>
+                                        </p:attrNameLst>
+                                      </p:cBhvr>
+                                      <p:to>
+                                        <p:strVal val="visible"/>
+                                      </p:to>
+                                    </p:set>
+                                  </p:childTnLst>
+                                </p:cTn>
+                              </p:par>
+                              <p:par>
+                                <p:cTn id="25" presetID="1" presetClass="entr" presetSubtype="0" fill="hold" nodeType="withEffect">
+                                  <p:stCondLst>
+                                    <p:cond delay="0"/>
+                                  </p:stCondLst>
+                                  <p:childTnLst>
+                                    <p:set>
+                                      <p:cBhvr>
+                                        <p:cTn id="26" dur="1" fill="hold">
+                                          <p:stCondLst>
+                                            <p:cond delay="0"/>
+                                          </p:stCondLst>
+                                        </p:cTn>
+                                        <p:tgtEl>
+                                          <p:spTgt spid="3">
+                                            <p:txEl>
+                                              <p:pRg st="6" end="6"/>
+                                            </p:txEl>
+                                          </p:spTgt>
+                                        </p:tgtEl>
+                                        <p:attrNameLst>
+                                          <p:attrName>style.visibility</p:attrName>
+                                        </p:attrNameLst>
+                                      </p:cBhvr>
+                                      <p:to>
+                                        <p:strVal val="visible"/>
+                                      </p:to>
+                                    </p:set>
+                                  </p:childTnLst>
+                                </p:cTn>
+                              </p:par>
+                              <p:par>
+                                <p:cTn id="27" presetID="1" presetClass="entr" presetSubtype="0" fill="hold" nodeType="withEffect">
+                                  <p:stCondLst>
+                                    <p:cond delay="0"/>
+                                  </p:stCondLst>
+                                  <p:childTnLst>
+                                    <p:set>
+                                      <p:cBhvr>
+                                        <p:cTn id="28" dur="1" fill="hold">
+                                          <p:stCondLst>
+                                            <p:cond delay="0"/>
+                                          </p:stCondLst>
+                                        </p:cTn>
+                                        <p:tgtEl>
+                                          <p:spTgt spid="11"/>
+                                        </p:tgtEl>
+                                        <p:attrNameLst>
+                                          <p:attrName>style.visibility</p:attrName>
+                                        </p:attrNameLst>
+                                      </p:cBhvr>
+                                      <p:to>
+                                        <p:strVal val="visible"/>
+                                      </p:to>
+                                    </p:set>
+                                  </p:childTnLst>
+                                </p:cTn>
+                              </p:par>
+                            </p:childTnLst>
+                          </p:cTn>
+                        </p:par>
+                      </p:childTnLst>
+                    </p:cTn>
+                  </p:par>
+                  <p:par>
+                    <p:cTn id="29" fill="hold">
+                      <p:stCondLst>
+                        <p:cond delay="indefinite"/>
+                      </p:stCondLst>
+                      <p:childTnLst>
+                        <p:par>
+                          <p:cTn id="30" fill="hold">
+                            <p:stCondLst>
+                              <p:cond delay="0"/>
+                            </p:stCondLst>
+                            <p:childTnLst>
+                              <p:par>
+                                <p:cTn id="31" presetID="1" presetClass="entr" presetSubtype="0" fill="hold" nodeType="clickEffect">
+                                  <p:stCondLst>
+                                    <p:cond delay="0"/>
+                                  </p:stCondLst>
+                                  <p:childTnLst>
+                                    <p:set>
+                                      <p:cBhvr>
+                                        <p:cTn id="32" dur="1" fill="hold">
+                                          <p:stCondLst>
+                                            <p:cond delay="0"/>
+                                          </p:stCondLst>
+                                        </p:cTn>
+                                        <p:tgtEl>
+                                          <p:spTgt spid="3">
+                                            <p:txEl>
+                                              <p:pRg st="7" end="7"/>
+                                            </p:txEl>
+                                          </p:spTgt>
+                                        </p:tgtEl>
+                                        <p:attrNameLst>
+                                          <p:attrName>style.visibility</p:attrName>
+                                        </p:attrNameLst>
+                                      </p:cBhvr>
+                                      <p:to>
+                                        <p:strVal val="visible"/>
+                                      </p:to>
+                                    </p:set>
+                                  </p:childTnLst>
+                                </p:cTn>
+                              </p:par>
+                              <p:par>
+                                <p:cTn id="33" presetID="1" presetClass="entr" presetSubtype="0" fill="hold" nodeType="withEffect">
+                                  <p:stCondLst>
+                                    <p:cond delay="0"/>
+                                  </p:stCondLst>
+                                  <p:childTnLst>
+                                    <p:set>
+                                      <p:cBhvr>
+                                        <p:cTn id="34" dur="1" fill="hold">
+                                          <p:stCondLst>
+                                            <p:cond delay="0"/>
+                                          </p:stCondLst>
+                                        </p:cTn>
+                                        <p:tgtEl>
+                                          <p:spTgt spid="13"/>
+                                        </p:tgtEl>
+                                        <p:attrNameLst>
+                                          <p:attrName>style.visibility</p:attrName>
+                                        </p:attrNameLst>
+                                      </p:cBhvr>
+                                      <p:to>
+                                        <p:strVal val="visible"/>
+                                      </p:to>
+                                    </p:set>
+                                  </p:childTnLst>
+                                </p:cTn>
+                              </p:par>
+                            </p:childTnLst>
+                          </p:cTn>
+                        </p:par>
+                      </p:childTnLst>
+                    </p:cTn>
+                  </p:par>
+                </p:childTnLst>
+              </p:cTn>
+              <p:prevCondLst>
+                <p:cond evt="onPrev" delay="0">
+                  <p:tgtEl>
+                    <p:sldTgt/>
+                  </p:tgtEl>
+                </p:cond>
+              </p:prevCondLst>
+              <p:nextCondLst>
+                <p:cond evt="onNext" delay="0">
+                  <p:tgtEl>
+                    <p:sldTgt/>
+                  </p:tgtEl>
+                </p:cond>
+              </p:nextCondLst>
+            </p:seq>
+          </p:childTnLst>
+        </p:cTn>
+      </p:par>
+    </p:tnLst>
+  </p:timing>
 </p:sld>
 </file>
 
@@ -5452,7 +6253,12 @@
             <p:ph idx="1"/>
           </p:nvPr>
         </p:nvSpPr>
-        <p:spPr/>
+        <p:spPr>
+          <a:xfrm>
+            <a:off x="838200" y="2141537"/>
+            <a:ext cx="10515600" cy="4351338"/>
+          </a:xfrm>
+        </p:spPr>
         <p:txBody>
           <a:bodyPr/>
           <a:lstStyle/>
@@ -5490,7 +6296,7 @@
         </p:blipFill>
         <p:spPr>
           <a:xfrm>
-            <a:off x="3723944" y="2381104"/>
+            <a:off x="1074095" y="3133458"/>
             <a:ext cx="4744112" cy="2004884"/>
           </a:xfrm>
           <a:prstGeom prst="rect">
@@ -5530,8 +6336,8 @@
         </p:blipFill>
         <p:spPr>
           <a:xfrm>
-            <a:off x="3890719" y="4520925"/>
-            <a:ext cx="4229690" cy="1971950"/>
+            <a:off x="6609687" y="3133458"/>
+            <a:ext cx="4300331" cy="2004884"/>
           </a:xfrm>
           <a:prstGeom prst="rect">
             <a:avLst/>
@@ -5825,6 +6631,188 @@
   <p:clrMapOvr>
     <a:masterClrMapping/>
   </p:clrMapOvr>
+  <p:timing>
+    <p:tnLst>
+      <p:par>
+        <p:cTn id="1" dur="indefinite" restart="never" nodeType="tmRoot">
+          <p:childTnLst>
+            <p:seq concurrent="1" nextAc="seek">
+              <p:cTn id="2" dur="indefinite" nodeType="mainSeq">
+                <p:childTnLst>
+                  <p:par>
+                    <p:cTn id="3" fill="hold">
+                      <p:stCondLst>
+                        <p:cond delay="indefinite"/>
+                      </p:stCondLst>
+                      <p:childTnLst>
+                        <p:par>
+                          <p:cTn id="4" fill="hold">
+                            <p:stCondLst>
+                              <p:cond delay="0"/>
+                            </p:stCondLst>
+                            <p:childTnLst>
+                              <p:par>
+                                <p:cTn id="5" presetID="1" presetClass="entr" presetSubtype="0" fill="hold" nodeType="clickEffect">
+                                  <p:stCondLst>
+                                    <p:cond delay="0"/>
+                                  </p:stCondLst>
+                                  <p:childTnLst>
+                                    <p:set>
+                                      <p:cBhvr>
+                                        <p:cTn id="6" dur="1" fill="hold">
+                                          <p:stCondLst>
+                                            <p:cond delay="0"/>
+                                          </p:stCondLst>
+                                        </p:cTn>
+                                        <p:tgtEl>
+                                          <p:spTgt spid="3">
+                                            <p:txEl>
+                                              <p:pRg st="5" end="5"/>
+                                            </p:txEl>
+                                          </p:spTgt>
+                                        </p:tgtEl>
+                                        <p:attrNameLst>
+                                          <p:attrName>style.visibility</p:attrName>
+                                        </p:attrNameLst>
+                                      </p:cBhvr>
+                                      <p:to>
+                                        <p:strVal val="visible"/>
+                                      </p:to>
+                                    </p:set>
+                                  </p:childTnLst>
+                                </p:cTn>
+                              </p:par>
+                              <p:par>
+                                <p:cTn id="7" presetID="1" presetClass="entr" presetSubtype="0" fill="hold" nodeType="withEffect">
+                                  <p:stCondLst>
+                                    <p:cond delay="0"/>
+                                  </p:stCondLst>
+                                  <p:childTnLst>
+                                    <p:set>
+                                      <p:cBhvr>
+                                        <p:cTn id="8" dur="1" fill="hold">
+                                          <p:stCondLst>
+                                            <p:cond delay="0"/>
+                                          </p:stCondLst>
+                                        </p:cTn>
+                                        <p:tgtEl>
+                                          <p:spTgt spid="7"/>
+                                        </p:tgtEl>
+                                        <p:attrNameLst>
+                                          <p:attrName>style.visibility</p:attrName>
+                                        </p:attrNameLst>
+                                      </p:cBhvr>
+                                      <p:to>
+                                        <p:strVal val="visible"/>
+                                      </p:to>
+                                    </p:set>
+                                  </p:childTnLst>
+                                </p:cTn>
+                              </p:par>
+                            </p:childTnLst>
+                          </p:cTn>
+                        </p:par>
+                      </p:childTnLst>
+                    </p:cTn>
+                  </p:par>
+                  <p:par>
+                    <p:cTn id="9" fill="hold">
+                      <p:stCondLst>
+                        <p:cond delay="indefinite"/>
+                      </p:stCondLst>
+                      <p:childTnLst>
+                        <p:par>
+                          <p:cTn id="10" fill="hold">
+                            <p:stCondLst>
+                              <p:cond delay="0"/>
+                            </p:stCondLst>
+                            <p:childTnLst>
+                              <p:par>
+                                <p:cTn id="11" presetID="1" presetClass="entr" presetSubtype="0" fill="hold" nodeType="clickEffect">
+                                  <p:stCondLst>
+                                    <p:cond delay="0"/>
+                                  </p:stCondLst>
+                                  <p:childTnLst>
+                                    <p:set>
+                                      <p:cBhvr>
+                                        <p:cTn id="12" dur="1" fill="hold">
+                                          <p:stCondLst>
+                                            <p:cond delay="0"/>
+                                          </p:stCondLst>
+                                        </p:cTn>
+                                        <p:tgtEl>
+                                          <p:spTgt spid="3">
+                                            <p:txEl>
+                                              <p:pRg st="8" end="8"/>
+                                            </p:txEl>
+                                          </p:spTgt>
+                                        </p:tgtEl>
+                                        <p:attrNameLst>
+                                          <p:attrName>style.visibility</p:attrName>
+                                        </p:attrNameLst>
+                                      </p:cBhvr>
+                                      <p:to>
+                                        <p:strVal val="visible"/>
+                                      </p:to>
+                                    </p:set>
+                                  </p:childTnLst>
+                                </p:cTn>
+                              </p:par>
+                              <p:par>
+                                <p:cTn id="13" presetID="1" presetClass="entr" presetSubtype="0" fill="hold" nodeType="withEffect">
+                                  <p:stCondLst>
+                                    <p:cond delay="0"/>
+                                  </p:stCondLst>
+                                  <p:childTnLst>
+                                    <p:set>
+                                      <p:cBhvr>
+                                        <p:cTn id="14" dur="1" fill="hold">
+                                          <p:stCondLst>
+                                            <p:cond delay="0"/>
+                                          </p:stCondLst>
+                                        </p:cTn>
+                                        <p:tgtEl>
+                                          <p:spTgt spid="6"/>
+                                        </p:tgtEl>
+                                        <p:attrNameLst>
+                                          <p:attrName>style.visibility</p:attrName>
+                                        </p:attrNameLst>
+                                      </p:cBhvr>
+                                      <p:to>
+                                        <p:strVal val="visible"/>
+                                      </p:to>
+                                    </p:set>
+                                  </p:childTnLst>
+                                </p:cTn>
+                              </p:par>
+                            </p:childTnLst>
+                          </p:cTn>
+                        </p:par>
+                      </p:childTnLst>
+                    </p:cTn>
+                  </p:par>
+                </p:childTnLst>
+              </p:cTn>
+              <p:prevCondLst>
+                <p:cond evt="onPrev" delay="0">
+                  <p:tgtEl>
+                    <p:sldTgt/>
+                  </p:tgtEl>
+                </p:cond>
+              </p:prevCondLst>
+              <p:nextCondLst>
+                <p:cond evt="onNext" delay="0">
+                  <p:tgtEl>
+                    <p:sldTgt/>
+                  </p:tgtEl>
+                </p:cond>
+              </p:nextCondLst>
+            </p:seq>
+          </p:childTnLst>
+        </p:cTn>
+      </p:par>
+    </p:tnLst>
+  </p:timing>
 </p:sld>
 </file>
 
@@ -6498,7 +7486,7 @@
           <p:nvPr/>
         </p:nvPicPr>
         <p:blipFill>
-          <a:blip r:embed="rId2"/>
+          <a:blip r:embed="rId3"/>
           <a:stretch>
             <a:fillRect/>
           </a:stretch>
@@ -6538,7 +7526,7 @@
           <p:nvPr/>
         </p:nvPicPr>
         <p:blipFill>
-          <a:blip r:embed="rId3"/>
+          <a:blip r:embed="rId4"/>
           <a:stretch>
             <a:fillRect/>
           </a:stretch>
@@ -6573,6 +7561,161 @@
   <p:clrMapOvr>
     <a:masterClrMapping/>
   </p:clrMapOvr>
+  <p:timing>
+    <p:tnLst>
+      <p:par>
+        <p:cTn id="1" dur="indefinite" restart="never" nodeType="tmRoot">
+          <p:childTnLst>
+            <p:seq concurrent="1" nextAc="seek">
+              <p:cTn id="2" dur="indefinite" nodeType="mainSeq">
+                <p:childTnLst>
+                  <p:par>
+                    <p:cTn id="3" fill="hold">
+                      <p:stCondLst>
+                        <p:cond delay="indefinite"/>
+                      </p:stCondLst>
+                      <p:childTnLst>
+                        <p:par>
+                          <p:cTn id="4" fill="hold">
+                            <p:stCondLst>
+                              <p:cond delay="0"/>
+                            </p:stCondLst>
+                            <p:childTnLst>
+                              <p:par>
+                                <p:cTn id="5" presetID="1" presetClass="entr" presetSubtype="0" fill="hold" nodeType="clickEffect">
+                                  <p:stCondLst>
+                                    <p:cond delay="0"/>
+                                  </p:stCondLst>
+                                  <p:childTnLst>
+                                    <p:set>
+                                      <p:cBhvr>
+                                        <p:cTn id="6" dur="1" fill="hold">
+                                          <p:stCondLst>
+                                            <p:cond delay="0"/>
+                                          </p:stCondLst>
+                                        </p:cTn>
+                                        <p:tgtEl>
+                                          <p:spTgt spid="3">
+                                            <p:txEl>
+                                              <p:pRg st="4" end="4"/>
+                                            </p:txEl>
+                                          </p:spTgt>
+                                        </p:tgtEl>
+                                        <p:attrNameLst>
+                                          <p:attrName>style.visibility</p:attrName>
+                                        </p:attrNameLst>
+                                      </p:cBhvr>
+                                      <p:to>
+                                        <p:strVal val="visible"/>
+                                      </p:to>
+                                    </p:set>
+                                  </p:childTnLst>
+                                </p:cTn>
+                              </p:par>
+                              <p:par>
+                                <p:cTn id="7" presetID="1" presetClass="entr" presetSubtype="0" fill="hold" nodeType="withEffect">
+                                  <p:stCondLst>
+                                    <p:cond delay="0"/>
+                                  </p:stCondLst>
+                                  <p:childTnLst>
+                                    <p:set>
+                                      <p:cBhvr>
+                                        <p:cTn id="8" dur="1" fill="hold">
+                                          <p:stCondLst>
+                                            <p:cond delay="0"/>
+                                          </p:stCondLst>
+                                        </p:cTn>
+                                        <p:tgtEl>
+                                          <p:spTgt spid="7"/>
+                                        </p:tgtEl>
+                                        <p:attrNameLst>
+                                          <p:attrName>style.visibility</p:attrName>
+                                        </p:attrNameLst>
+                                      </p:cBhvr>
+                                      <p:to>
+                                        <p:strVal val="visible"/>
+                                      </p:to>
+                                    </p:set>
+                                  </p:childTnLst>
+                                </p:cTn>
+                              </p:par>
+                            </p:childTnLst>
+                          </p:cTn>
+                        </p:par>
+                      </p:childTnLst>
+                    </p:cTn>
+                  </p:par>
+                  <p:par>
+                    <p:cTn id="9" fill="hold">
+                      <p:stCondLst>
+                        <p:cond delay="indefinite"/>
+                      </p:stCondLst>
+                      <p:childTnLst>
+                        <p:par>
+                          <p:cTn id="10" fill="hold">
+                            <p:stCondLst>
+                              <p:cond delay="0"/>
+                            </p:stCondLst>
+                            <p:childTnLst>
+                              <p:par>
+                                <p:cTn id="11" presetID="1" presetClass="entr" presetSubtype="0" fill="hold" nodeType="clickEffect">
+                                  <p:stCondLst>
+                                    <p:cond delay="0"/>
+                                  </p:stCondLst>
+                                  <p:childTnLst>
+                                    <p:set>
+                                      <p:cBhvr>
+                                        <p:cTn id="12" dur="1" fill="hold">
+                                          <p:stCondLst>
+                                            <p:cond delay="0"/>
+                                          </p:stCondLst>
+                                        </p:cTn>
+                                        <p:tgtEl>
+                                          <p:spTgt spid="3">
+                                            <p:txEl>
+                                              <p:pRg st="7" end="7"/>
+                                            </p:txEl>
+                                          </p:spTgt>
+                                        </p:tgtEl>
+                                        <p:attrNameLst>
+                                          <p:attrName>style.visibility</p:attrName>
+                                        </p:attrNameLst>
+                                      </p:cBhvr>
+                                      <p:to>
+                                        <p:strVal val="visible"/>
+                                      </p:to>
+                                    </p:set>
+                                  </p:childTnLst>
+                                </p:cTn>
+                              </p:par>
+                            </p:childTnLst>
+                          </p:cTn>
+                        </p:par>
+                      </p:childTnLst>
+                    </p:cTn>
+                  </p:par>
+                </p:childTnLst>
+              </p:cTn>
+              <p:prevCondLst>
+                <p:cond evt="onPrev" delay="0">
+                  <p:tgtEl>
+                    <p:sldTgt/>
+                  </p:tgtEl>
+                </p:cond>
+              </p:prevCondLst>
+              <p:nextCondLst>
+                <p:cond evt="onNext" delay="0">
+                  <p:tgtEl>
+                    <p:sldTgt/>
+                  </p:tgtEl>
+                </p:cond>
+              </p:nextCondLst>
+            </p:seq>
+          </p:childTnLst>
+        </p:cTn>
+      </p:par>
+    </p:tnLst>
+  </p:timing>
 </p:sld>
 </file>
 

</xml_diff>